<commit_message>
Presentation: v0.1.8 explainer assets; README: correct license note
Explainer video (4:30, v0.1.8 title slide), both source decks, and the narration
script - "large language model" thesis wording throughout. README License section
now says MIT - see LICENSE.
</commit_message>
<xml_diff>
--- a/Presentation/Insight-Engine-Video-Deck.pptx
+++ b/Presentation/Insight-Engine-Video-Deck.pptx
@@ -1865,7 +1865,7 @@
                 <a:ea typeface="Calibri" pitchFamily="34" charset="-122"/>
                 <a:cs typeface="Calibri" pitchFamily="34" charset="-120"/>
               </a:rPr>
-              <a:t>Built as a Claude Code &amp; Claude Cowork plugin    ·    v0.1.7</a:t>
+              <a:t>Built as a Claude Code &amp; Claude Cowork plugin    ·    v0.1.8</a:t>
             </a:r>
             <a:endParaRPr lang="en-US" sz="1700" dirty="0"/>
           </a:p>
@@ -2080,6 +2080,10 @@
           </a:solidFill>
           <a:ln/>
         </p:spPr>
+        <p:txBody>
+          <a:bodyPr/>
+          <a:p/>
+        </p:txBody>
       </p:sp>
       <p:sp>
         <p:nvSpPr>
@@ -2302,6 +2306,10 @@
             </a:outerShdw>
           </a:effectLst>
         </p:spPr>
+        <p:txBody>
+          <a:bodyPr/>
+          <a:p/>
+        </p:txBody>
       </p:sp>
       <p:sp>
         <p:nvSpPr>
@@ -2414,6 +2422,10 @@
             </a:outerShdw>
           </a:effectLst>
         </p:spPr>
+        <p:txBody>
+          <a:bodyPr/>
+          <a:p/>
+        </p:txBody>
       </p:sp>
       <p:sp>
         <p:nvSpPr>
@@ -2526,6 +2538,10 @@
             </a:outerShdw>
           </a:effectLst>
         </p:spPr>
+        <p:txBody>
+          <a:bodyPr/>
+          <a:p/>
+        </p:txBody>
       </p:sp>
       <p:sp>
         <p:nvSpPr>
@@ -2734,6 +2750,10 @@
           </a:solidFill>
           <a:ln/>
         </p:spPr>
+        <p:txBody>
+          <a:bodyPr/>
+          <a:p/>
+        </p:txBody>
       </p:sp>
       <p:sp>
         <p:nvSpPr>
@@ -2832,6 +2852,10 @@
           </a:solidFill>
           <a:ln/>
         </p:spPr>
+        <p:txBody>
+          <a:bodyPr/>
+          <a:p/>
+        </p:txBody>
       </p:sp>
       <p:sp>
         <p:nvSpPr>
@@ -2930,6 +2954,10 @@
           </a:solidFill>
           <a:ln/>
         </p:spPr>
+        <p:txBody>
+          <a:bodyPr/>
+          <a:p/>
+        </p:txBody>
       </p:sp>
       <p:sp>
         <p:nvSpPr>
@@ -3028,6 +3056,10 @@
           </a:solidFill>
           <a:ln/>
         </p:spPr>
+        <p:txBody>
+          <a:bodyPr/>
+          <a:p/>
+        </p:txBody>
       </p:sp>
       <p:sp>
         <p:nvSpPr>
@@ -3289,6 +3321,10 @@
             </a:outerShdw>
           </a:effectLst>
         </p:spPr>
+        <p:txBody>
+          <a:bodyPr/>
+          <a:p/>
+        </p:txBody>
       </p:sp>
       <p:sp>
         <p:nvSpPr>
@@ -3401,6 +3437,10 @@
             </a:outerShdw>
           </a:effectLst>
         </p:spPr>
+        <p:txBody>
+          <a:bodyPr/>
+          <a:p/>
+        </p:txBody>
       </p:sp>
       <p:sp>
         <p:nvSpPr>
@@ -3513,6 +3553,10 @@
             </a:outerShdw>
           </a:effectLst>
         </p:spPr>
+        <p:txBody>
+          <a:bodyPr/>
+          <a:p/>
+        </p:txBody>
       </p:sp>
       <p:sp>
         <p:nvSpPr>
@@ -3625,6 +3669,10 @@
             </a:outerShdw>
           </a:effectLst>
         </p:spPr>
+        <p:txBody>
+          <a:bodyPr/>
+          <a:p/>
+        </p:txBody>
       </p:sp>
       <p:sp>
         <p:nvSpPr>
@@ -3737,6 +3785,10 @@
             </a:outerShdw>
           </a:effectLst>
         </p:spPr>
+        <p:txBody>
+          <a:bodyPr/>
+          <a:p/>
+        </p:txBody>
       </p:sp>
       <p:sp>
         <p:nvSpPr>
@@ -3849,6 +3901,10 @@
             </a:outerShdw>
           </a:effectLst>
         </p:spPr>
+        <p:txBody>
+          <a:bodyPr/>
+          <a:p/>
+        </p:txBody>
       </p:sp>
       <p:sp>
         <p:nvSpPr>
@@ -3961,6 +4017,10 @@
             </a:outerShdw>
           </a:effectLst>
         </p:spPr>
+        <p:txBody>
+          <a:bodyPr/>
+          <a:p/>
+        </p:txBody>
       </p:sp>
       <p:sp>
         <p:nvSpPr>
@@ -4073,6 +4133,10 @@
             </a:outerShdw>
           </a:effectLst>
         </p:spPr>
+        <p:txBody>
+          <a:bodyPr/>
+          <a:p/>
+        </p:txBody>
       </p:sp>
       <p:sp>
         <p:nvSpPr>
@@ -4320,6 +4384,10 @@
           </a:solidFill>
           <a:ln/>
         </p:spPr>
+        <p:txBody>
+          <a:bodyPr/>
+          <a:p/>
+        </p:txBody>
       </p:sp>
       <p:sp>
         <p:nvSpPr>
@@ -4418,6 +4486,10 @@
           </a:solidFill>
           <a:ln/>
         </p:spPr>
+        <p:txBody>
+          <a:bodyPr/>
+          <a:p/>
+        </p:txBody>
       </p:sp>
       <p:sp>
         <p:nvSpPr>
@@ -4516,6 +4588,10 @@
           </a:solidFill>
           <a:ln/>
         </p:spPr>
+        <p:txBody>
+          <a:bodyPr/>
+          <a:p/>
+        </p:txBody>
       </p:sp>
       <p:sp>
         <p:nvSpPr>
@@ -4614,6 +4690,10 @@
           </a:solidFill>
           <a:ln/>
         </p:spPr>
+        <p:txBody>
+          <a:bodyPr/>
+          <a:p/>
+        </p:txBody>
       </p:sp>
       <p:sp>
         <p:nvSpPr>
@@ -4712,6 +4792,10 @@
           </a:solidFill>
           <a:ln/>
         </p:spPr>
+        <p:txBody>
+          <a:bodyPr/>
+          <a:p/>
+        </p:txBody>
       </p:sp>
       <p:sp>
         <p:nvSpPr>
@@ -4966,6 +5050,10 @@
             <a:prstDash val="solid"/>
           </a:ln>
         </p:spPr>
+        <p:txBody>
+          <a:bodyPr/>
+          <a:p/>
+        </p:txBody>
       </p:sp>
       <p:sp>
         <p:nvSpPr>
@@ -5032,6 +5120,10 @@
             <a:prstDash val="solid"/>
           </a:ln>
         </p:spPr>
+        <p:txBody>
+          <a:bodyPr/>
+          <a:p/>
+        </p:txBody>
       </p:sp>
       <p:sp>
         <p:nvSpPr>
@@ -5105,6 +5197,10 @@
             </a:outerShdw>
           </a:effectLst>
         </p:spPr>
+        <p:txBody>
+          <a:bodyPr/>
+          <a:p/>
+        </p:txBody>
       </p:sp>
       <p:sp>
         <p:nvSpPr>
@@ -5171,6 +5267,10 @@
             <a:prstDash val="solid"/>
           </a:ln>
         </p:spPr>
+        <p:txBody>
+          <a:bodyPr/>
+          <a:p/>
+        </p:txBody>
       </p:sp>
       <p:sp>
         <p:nvSpPr>
@@ -5193,6 +5293,10 @@
           </a:solidFill>
           <a:ln/>
         </p:spPr>
+        <p:txBody>
+          <a:bodyPr/>
+          <a:p/>
+        </p:txBody>
       </p:sp>
       <p:sp>
         <p:nvSpPr>
@@ -5298,6 +5402,10 @@
             <a:prstDash val="solid"/>
           </a:ln>
         </p:spPr>
+        <p:txBody>
+          <a:bodyPr/>
+          <a:p/>
+        </p:txBody>
       </p:sp>
       <p:sp>
         <p:nvSpPr>
@@ -5320,6 +5428,10 @@
           </a:solidFill>
           <a:ln/>
         </p:spPr>
+        <p:txBody>
+          <a:bodyPr/>
+          <a:p/>
+        </p:txBody>
       </p:sp>
       <p:sp>
         <p:nvSpPr>
@@ -5425,6 +5537,10 @@
             <a:prstDash val="solid"/>
           </a:ln>
         </p:spPr>
+        <p:txBody>
+          <a:bodyPr/>
+          <a:p/>
+        </p:txBody>
       </p:sp>
       <p:sp>
         <p:nvSpPr>
@@ -5447,6 +5563,10 @@
           </a:solidFill>
           <a:ln/>
         </p:spPr>
+        <p:txBody>
+          <a:bodyPr/>
+          <a:p/>
+        </p:txBody>
       </p:sp>
       <p:sp>
         <p:nvSpPr>
@@ -5552,6 +5672,10 @@
             <a:prstDash val="solid"/>
           </a:ln>
         </p:spPr>
+        <p:txBody>
+          <a:bodyPr/>
+          <a:p/>
+        </p:txBody>
       </p:sp>
       <p:sp>
         <p:nvSpPr>
@@ -5574,6 +5698,10 @@
           </a:solidFill>
           <a:ln/>
         </p:spPr>
+        <p:txBody>
+          <a:bodyPr/>
+          <a:p/>
+        </p:txBody>
       </p:sp>
       <p:sp>
         <p:nvSpPr>
@@ -5679,6 +5807,10 @@
             <a:prstDash val="solid"/>
           </a:ln>
         </p:spPr>
+        <p:txBody>
+          <a:bodyPr/>
+          <a:p/>
+        </p:txBody>
       </p:sp>
       <p:sp>
         <p:nvSpPr>
@@ -5701,6 +5833,10 @@
           </a:solidFill>
           <a:ln/>
         </p:spPr>
+        <p:txBody>
+          <a:bodyPr/>
+          <a:p/>
+        </p:txBody>
       </p:sp>
       <p:sp>
         <p:nvSpPr>
@@ -5806,6 +5942,10 @@
             <a:prstDash val="solid"/>
           </a:ln>
         </p:spPr>
+        <p:txBody>
+          <a:bodyPr/>
+          <a:p/>
+        </p:txBody>
       </p:sp>
       <p:sp>
         <p:nvSpPr>
@@ -5828,6 +5968,10 @@
           </a:solidFill>
           <a:ln/>
         </p:spPr>
+        <p:txBody>
+          <a:bodyPr/>
+          <a:p/>
+        </p:txBody>
       </p:sp>
       <p:sp>
         <p:nvSpPr>
@@ -5933,6 +6077,10 @@
             <a:prstDash val="solid"/>
           </a:ln>
         </p:spPr>
+        <p:txBody>
+          <a:bodyPr/>
+          <a:p/>
+        </p:txBody>
       </p:sp>
       <p:sp>
         <p:nvSpPr>
@@ -5955,6 +6103,10 @@
           </a:solidFill>
           <a:ln/>
         </p:spPr>
+        <p:txBody>
+          <a:bodyPr/>
+          <a:p/>
+        </p:txBody>
       </p:sp>
       <p:sp>
         <p:nvSpPr>
@@ -6060,6 +6212,10 @@
             <a:prstDash val="solid"/>
           </a:ln>
         </p:spPr>
+        <p:txBody>
+          <a:bodyPr/>
+          <a:p/>
+        </p:txBody>
       </p:sp>
       <p:sp>
         <p:nvSpPr>
@@ -6082,6 +6238,10 @@
           </a:solidFill>
           <a:ln/>
         </p:spPr>
+        <p:txBody>
+          <a:bodyPr/>
+          <a:p/>
+        </p:txBody>
       </p:sp>
       <p:sp>
         <p:nvSpPr>
@@ -6187,6 +6347,10 @@
             <a:prstDash val="solid"/>
           </a:ln>
         </p:spPr>
+        <p:txBody>
+          <a:bodyPr/>
+          <a:p/>
+        </p:txBody>
       </p:sp>
       <p:sp>
         <p:nvSpPr>
@@ -6448,6 +6612,10 @@
             </a:outerShdw>
           </a:effectLst>
         </p:spPr>
+        <p:txBody>
+          <a:bodyPr/>
+          <a:p/>
+        </p:txBody>
       </p:sp>
       <p:sp>
         <p:nvSpPr>
@@ -6548,6 +6716,10 @@
           </a:solidFill>
           <a:ln/>
         </p:spPr>
+        <p:txBody>
+          <a:bodyPr/>
+          <a:p/>
+        </p:txBody>
       </p:sp>
       <p:sp>
         <p:nvSpPr>
@@ -6660,6 +6832,10 @@
             </a:outerShdw>
           </a:effectLst>
         </p:spPr>
+        <p:txBody>
+          <a:bodyPr/>
+          <a:p/>
+        </p:txBody>
       </p:sp>
       <p:sp>
         <p:nvSpPr>
@@ -6760,6 +6936,10 @@
           </a:solidFill>
           <a:ln/>
         </p:spPr>
+        <p:txBody>
+          <a:bodyPr/>
+          <a:p/>
+        </p:txBody>
       </p:sp>
       <p:sp>
         <p:nvSpPr>
@@ -6872,6 +7052,10 @@
             </a:outerShdw>
           </a:effectLst>
         </p:spPr>
+        <p:txBody>
+          <a:bodyPr/>
+          <a:p/>
+        </p:txBody>
       </p:sp>
       <p:sp>
         <p:nvSpPr>
@@ -6972,6 +7156,10 @@
           </a:solidFill>
           <a:ln/>
         </p:spPr>
+        <p:txBody>
+          <a:bodyPr/>
+          <a:p/>
+        </p:txBody>
       </p:sp>
       <p:sp>
         <p:nvSpPr>
@@ -7084,6 +7272,10 @@
             </a:outerShdw>
           </a:effectLst>
         </p:spPr>
+        <p:txBody>
+          <a:bodyPr/>
+          <a:p/>
+        </p:txBody>
       </p:sp>
       <p:sp>
         <p:nvSpPr>
@@ -7184,6 +7376,10 @@
           </a:solidFill>
           <a:ln/>
         </p:spPr>
+        <p:txBody>
+          <a:bodyPr/>
+          <a:p/>
+        </p:txBody>
       </p:sp>
       <p:sp>
         <p:nvSpPr>
@@ -7257,6 +7453,10 @@
             </a:outerShdw>
           </a:effectLst>
         </p:spPr>
+        <p:txBody>
+          <a:bodyPr/>
+          <a:p/>
+        </p:txBody>
       </p:sp>
       <p:sp>
         <p:nvSpPr>
@@ -7357,6 +7557,10 @@
           </a:solidFill>
           <a:ln/>
         </p:spPr>
+        <p:txBody>
+          <a:bodyPr/>
+          <a:p/>
+        </p:txBody>
       </p:sp>
       <p:sp>
         <p:nvSpPr>
@@ -7469,6 +7673,10 @@
             </a:outerShdw>
           </a:effectLst>
         </p:spPr>
+        <p:txBody>
+          <a:bodyPr/>
+          <a:p/>
+        </p:txBody>
       </p:sp>
       <p:sp>
         <p:nvSpPr>
@@ -7569,6 +7777,10 @@
           </a:solidFill>
           <a:ln/>
         </p:spPr>
+        <p:txBody>
+          <a:bodyPr/>
+          <a:p/>
+        </p:txBody>
       </p:sp>
       <p:sp>
         <p:nvSpPr>
@@ -7681,6 +7893,10 @@
             </a:outerShdw>
           </a:effectLst>
         </p:spPr>
+        <p:txBody>
+          <a:bodyPr/>
+          <a:p/>
+        </p:txBody>
       </p:sp>
       <p:sp>
         <p:nvSpPr>
@@ -7781,6 +7997,10 @@
           </a:solidFill>
           <a:ln/>
         </p:spPr>
+        <p:txBody>
+          <a:bodyPr/>
+          <a:p/>
+        </p:txBody>
       </p:sp>
       <p:sp>
         <p:nvSpPr>
@@ -7893,6 +8113,10 @@
             </a:outerShdw>
           </a:effectLst>
         </p:spPr>
+        <p:txBody>
+          <a:bodyPr/>
+          <a:p/>
+        </p:txBody>
       </p:sp>
       <p:sp>
         <p:nvSpPr>
@@ -7993,6 +8217,10 @@
           </a:solidFill>
           <a:ln/>
         </p:spPr>
+        <p:txBody>
+          <a:bodyPr/>
+          <a:p/>
+        </p:txBody>
       </p:sp>
       <p:sp>
         <p:nvSpPr>
@@ -8254,6 +8482,10 @@
             </a:outerShdw>
           </a:effectLst>
         </p:spPr>
+        <p:txBody>
+          <a:bodyPr/>
+          <a:p/>
+        </p:txBody>
       </p:sp>
       <p:sp>
         <p:nvSpPr>
@@ -8366,6 +8598,10 @@
             </a:outerShdw>
           </a:effectLst>
         </p:spPr>
+        <p:txBody>
+          <a:bodyPr/>
+          <a:p/>
+        </p:txBody>
       </p:sp>
       <p:sp>
         <p:nvSpPr>
@@ -8478,6 +8714,10 @@
             </a:outerShdw>
           </a:effectLst>
         </p:spPr>
+        <p:txBody>
+          <a:bodyPr/>
+          <a:p/>
+        </p:txBody>
       </p:sp>
       <p:sp>
         <p:nvSpPr>
@@ -8590,6 +8830,10 @@
             </a:outerShdw>
           </a:effectLst>
         </p:spPr>
+        <p:txBody>
+          <a:bodyPr/>
+          <a:p/>
+        </p:txBody>
       </p:sp>
       <p:sp>
         <p:nvSpPr>
@@ -8702,6 +8946,10 @@
             </a:outerShdw>
           </a:effectLst>
         </p:spPr>
+        <p:txBody>
+          <a:bodyPr/>
+          <a:p/>
+        </p:txBody>
       </p:sp>
       <p:sp>
         <p:nvSpPr>
@@ -8924,6 +9172,10 @@
             </a:outerShdw>
           </a:effectLst>
         </p:spPr>
+        <p:txBody>
+          <a:bodyPr/>
+          <a:p/>
+        </p:txBody>
       </p:sp>
       <p:sp>
         <p:nvSpPr>
@@ -9124,6 +9376,10 @@
             </a:outerShdw>
           </a:effectLst>
         </p:spPr>
+        <p:txBody>
+          <a:bodyPr/>
+          <a:p/>
+        </p:txBody>
       </p:sp>
       <p:sp>
         <p:nvSpPr>
@@ -9303,6 +9559,10 @@
             </a:outerShdw>
           </a:effectLst>
         </p:spPr>
+        <p:txBody>
+          <a:bodyPr/>
+          <a:p/>
+        </p:txBody>
       </p:sp>
       <p:sp>
         <p:nvSpPr>

</xml_diff>